<commit_message>
Match PPTX template to the tuned Canva design
Co-Authored-By: Claude Opus 5.5 (1M context) <noreply@anthropic.com>
Claude-Session: https://claude.ai/code/session_0117s87PNoucLM6Rq8ssybQn
</commit_message>
<xml_diff>
--- a/canva-templates/sunstar-news-poster-template.pptx
+++ b/canva-templates/sunstar-news-poster-template.pptx
@@ -3144,7 +3144,7 @@
         </p:nvSpPr>
         <p:spPr>
           <a:xfrm>
-            <a:off x="8048625" y="1428750"/>
+            <a:off x="8048625" y="1666875"/>
             <a:ext cx="1704975" cy="5238750"/>
           </a:xfrm>
           <a:prstGeom prst="rect">
@@ -3313,8 +3313,8 @@
         </p:nvSpPr>
         <p:spPr>
           <a:xfrm>
-            <a:off x="571500" y="5048250"/>
-            <a:ext cx="4476750" cy="1095375"/>
+            <a:off x="571500" y="5143500"/>
+            <a:ext cx="5334000" cy="1095375"/>
           </a:xfrm>
           <a:prstGeom prst="rect">
             <a:avLst/>
@@ -3329,7 +3329,7 @@
           <a:p>
             <a:pPr algn="l">
               <a:lnSpc>
-                <a:spcPct val="98000"/>
+                <a:spcPct val="85000"/>
               </a:lnSpc>
             </a:pPr>
             <a:r>
@@ -3339,7 +3339,7 @@
                 </a:solidFill>
                 <a:latin typeface="Anton"/>
               </a:rPr>
-              <a:t>HIGHLIGHT LINE,</a:t>
+              <a:t>VP SARA,</a:t>
             </a:r>
           </a:p>
         </p:txBody>
@@ -3352,8 +3352,8 @@
         </p:nvSpPr>
         <p:spPr>
           <a:xfrm>
-            <a:off x="571500" y="6172200"/>
-            <a:ext cx="4476750" cy="4476750"/>
+            <a:off x="571500" y="6210300"/>
+            <a:ext cx="5334000" cy="4476750"/>
           </a:xfrm>
           <a:prstGeom prst="rect">
             <a:avLst/>
@@ -3368,7 +3368,7 @@
           <a:p>
             <a:pPr algn="l">
               <a:lnSpc>
-                <a:spcPct val="98000"/>
+                <a:spcPct val="85000"/>
               </a:lnSpc>
             </a:pPr>
             <a:r>
@@ -3378,13 +3378,13 @@
                 </a:solidFill>
                 <a:latin typeface="Anton"/>
               </a:rPr>
-              <a:t>HEADLINE CONTINUES</a:t>
+              <a:t>HUSBAND’S</a:t>
             </a:r>
           </a:p>
           <a:p>
             <a:pPr algn="l">
               <a:lnSpc>
-                <a:spcPct val="98000"/>
+                <a:spcPct val="85000"/>
               </a:lnSpc>
             </a:pPr>
             <a:r>
@@ -3394,13 +3394,13 @@
                 </a:solidFill>
                 <a:latin typeface="Anton"/>
               </a:rPr>
-              <a:t>HERE IN WHITE</a:t>
+              <a:t>NET WORTH</a:t>
             </a:r>
           </a:p>
           <a:p>
             <a:pPr algn="l">
               <a:lnSpc>
-                <a:spcPct val="98000"/>
+                <a:spcPct val="85000"/>
               </a:lnSpc>
             </a:pPr>
             <a:r>
@@ -3410,13 +3410,13 @@
                 </a:solidFill>
                 <a:latin typeface="Anton"/>
               </a:rPr>
-              <a:t>UP TO FOUR</a:t>
+              <a:t>AT P98M</a:t>
             </a:r>
           </a:p>
           <a:p>
             <a:pPr algn="l">
               <a:lnSpc>
-                <a:spcPct val="98000"/>
+                <a:spcPct val="85000"/>
               </a:lnSpc>
             </a:pPr>
             <a:r>
@@ -3426,7 +3426,7 @@
                 </a:solidFill>
                 <a:latin typeface="Anton"/>
               </a:rPr>
-              <a:t>LINES</a:t>
+              <a:t>IN 2025</a:t>
             </a:r>
           </a:p>
         </p:txBody>

</xml_diff>